<commit_message>
Deck: rename backup slides to Extra clarification
Co-Authored-By: Claude Opus 5.5 <noreply@anthropic.com>
</commit_message>
<xml_diff>
--- a/presentation/Sentiment_Midterms_Summary.pptx
+++ b/presentation/Sentiment_Midterms_Summary.pptx
@@ -124,25 +124,25 @@
   <p:extLst>
     <p:ext uri="{521415D9-36F7-43E2-AB2F-B90AF26B5E84}">
       <p14:sectionLst xmlns:p14="http://schemas.microsoft.com/office/powerpoint/2010/main">
-        <p14:section name="Question" id="{a921950d-5b00-f043-f4db-1dc3c42b499c}">
+        <p14:section name="Question" id="{33d14c0f-1c42-7557-f86d-a3316a21de77}">
           <p14:sldIdLst>
             <p14:sldId id="256"/>
             <p14:sldId id="257"/>
           </p14:sldIdLst>
         </p14:section>
-        <p14:section name="Approach" id="{4577d273-ab55-177f-2221-76f9a86dace1}">
+        <p14:section name="Approach" id="{40c31b20-55e2-ba54-1fd8-08816e4a828c}">
           <p14:sldIdLst>
             <p14:sldId id="258"/>
             <p14:sldId id="259"/>
           </p14:sldIdLst>
         </p14:section>
-        <p14:section name="Who" id="{acfe78a5-6545-e3a7-2854-288f04aa42b4}">
+        <p14:section name="Who" id="{98ed16e2-d2a7-36cb-84b1-dab3a2b4aa9c}">
           <p14:sldIdLst>
             <p14:sldId id="260"/>
             <p14:sldId id="261"/>
           </p14:sldIdLst>
         </p14:section>
-        <p14:section name="Why" id="{890d6445-3554-14d1-c2e1-6175ed3575d6}">
+        <p14:section name="Why" id="{49f7c477-89aa-9654-fd04-04f0ac526b93}">
           <p14:sldIdLst>
             <p14:sldId id="262"/>
             <p14:sldId id="263"/>
@@ -151,20 +151,20 @@
             <p14:sldId id="266"/>
           </p14:sldIdLst>
         </p14:section>
-        <p14:section name="Media" id="{9a02d32f-fa5b-05f3-3153-88314ee6538f}">
+        <p14:section name="Media" id="{15929bcb-7e83-e698-993c-800b350da609}">
           <p14:sldIdLst>
             <p14:sldId id="267"/>
             <p14:sldId id="268"/>
           </p14:sldIdLst>
         </p14:section>
-        <p14:section name="So what" id="{373b5f86-1532-b554-a66a-9b0f7b0f09a2}">
+        <p14:section name="So what" id="{a250556c-cc8b-9e25-dd40-3f4b627df8f9}">
           <p14:sldIdLst>
             <p14:sldId id="269"/>
             <p14:sldId id="270"/>
             <p14:sldId id="271"/>
           </p14:sldIdLst>
         </p14:section>
-        <p14:section name="Backup" id="{e238ce31-07b2-1049-4eb2-ca45cf44465c}">
+        <p14:section name="Extra clarification" id="{90d066b1-77fe-d172-2c6f-97ddf97271ac}">
           <p14:sldIdLst>
             <p14:sldId id="272"/>
             <p14:sldId id="273"/>
@@ -5650,7 +5650,7 @@
           <a:p>
             <a:r>
               <a:rPr lang="en-US" dirty="0"/>
-              <a:t>Backup for questions: one-line answers to the six research questions the brief requires.</a:t>
+              <a:t>Extra clarification for questions: one-line answers to the six research questions the brief requires.</a:t>
             </a:r>
             <a:endParaRPr lang="en-US" dirty="0"/>
           </a:p>
@@ -5738,7 +5738,7 @@
           <a:p>
             <a:r>
               <a:rPr lang="en-US" dirty="0"/>
-              <a:t>Backup for questions: our causal-design proposal (the brief's third option) and the honest limits of the study.</a:t>
+              <a:t>Extra clarification for questions: our causal-design proposal (the brief's third option) and the honest limits of the study.</a:t>
             </a:r>
             <a:endParaRPr lang="en-US" dirty="0"/>
           </a:p>
@@ -10352,7 +10352,7 @@
                 <a:ea typeface="Cambria" pitchFamily="34" charset="-122"/>
                 <a:cs typeface="Cambria" pitchFamily="34" charset="-120"/>
               </a:rPr>
-              <a:t>Backup: answers to the six required questions</a:t>
+              <a:t>Extra clarification: answers to the six required questions</a:t>
             </a:r>
             <a:endParaRPr lang="en-US" sz="3000" dirty="0"/>
           </a:p>
@@ -11285,7 +11285,7 @@
                 <a:ea typeface="Cambria" pitchFamily="34" charset="-122"/>
                 <a:cs typeface="Cambria" pitchFamily="34" charset="-120"/>
               </a:rPr>
-              <a:t>Backup: how we would prove cause — and our limits</a:t>
+              <a:t>Extra clarification: how we would prove cause — and our limits</a:t>
             </a:r>
             <a:endParaRPr lang="en-US" sz="3000" dirty="0"/>
           </a:p>

</xml_diff>

<commit_message>
Deck: shorten extra-clarification title
Co-Authored-By: Claude Opus 5.5 <noreply@anthropic.com>
</commit_message>
<xml_diff>
--- a/presentation/Sentiment_Midterms_Summary.pptx
+++ b/presentation/Sentiment_Midterms_Summary.pptx
@@ -124,25 +124,25 @@
   <p:extLst>
     <p:ext uri="{521415D9-36F7-43E2-AB2F-B90AF26B5E84}">
       <p14:sectionLst xmlns:p14="http://schemas.microsoft.com/office/powerpoint/2010/main">
-        <p14:section name="Question" id="{33d14c0f-1c42-7557-f86d-a3316a21de77}">
+        <p14:section name="Question" id="{36a789dd-e9de-a9b7-b2d2-844930be87b5}">
           <p14:sldIdLst>
             <p14:sldId id="256"/>
             <p14:sldId id="257"/>
           </p14:sldIdLst>
         </p14:section>
-        <p14:section name="Approach" id="{40c31b20-55e2-ba54-1fd8-08816e4a828c}">
+        <p14:section name="Approach" id="{3625bff1-aedb-5221-dc3b-5219b236a836}">
           <p14:sldIdLst>
             <p14:sldId id="258"/>
             <p14:sldId id="259"/>
           </p14:sldIdLst>
         </p14:section>
-        <p14:section name="Who" id="{98ed16e2-d2a7-36cb-84b1-dab3a2b4aa9c}">
+        <p14:section name="Who" id="{4418e372-bfac-944d-87ec-be83591b55a1}">
           <p14:sldIdLst>
             <p14:sldId id="260"/>
             <p14:sldId id="261"/>
           </p14:sldIdLst>
         </p14:section>
-        <p14:section name="Why" id="{49f7c477-89aa-9654-fd04-04f0ac526b93}">
+        <p14:section name="Why" id="{218aec60-db49-84b7-666b-b50bc6ed1cbd}">
           <p14:sldIdLst>
             <p14:sldId id="262"/>
             <p14:sldId id="263"/>
@@ -151,20 +151,20 @@
             <p14:sldId id="266"/>
           </p14:sldIdLst>
         </p14:section>
-        <p14:section name="Media" id="{15929bcb-7e83-e698-993c-800b350da609}">
+        <p14:section name="Media" id="{5de7b180-e585-7992-0e3e-251d019c90fe}">
           <p14:sldIdLst>
             <p14:sldId id="267"/>
             <p14:sldId id="268"/>
           </p14:sldIdLst>
         </p14:section>
-        <p14:section name="So what" id="{a250556c-cc8b-9e25-dd40-3f4b627df8f9}">
+        <p14:section name="So what" id="{2c0db3ab-87bc-f4e8-ac92-0304ce89a299}">
           <p14:sldIdLst>
             <p14:sldId id="269"/>
             <p14:sldId id="270"/>
             <p14:sldId id="271"/>
           </p14:sldIdLst>
         </p14:section>
-        <p14:section name="Extra clarification" id="{90d066b1-77fe-d172-2c6f-97ddf97271ac}">
+        <p14:section name="Extra clarification" id="{c9239acd-8028-ee87-db36-4f1f7d03e35b}">
           <p14:sldIdLst>
             <p14:sldId id="272"/>
             <p14:sldId id="273"/>
@@ -11285,7 +11285,7 @@
                 <a:ea typeface="Cambria" pitchFamily="34" charset="-122"/>
                 <a:cs typeface="Cambria" pitchFamily="34" charset="-120"/>
               </a:rPr>
-              <a:t>Extra clarification: how we would prove cause — and our limits</a:t>
+              <a:t>Extra clarification: proving cause, and our limits</a:t>
             </a:r>
             <a:endParaRPr lang="en-US" sz="3000" dirty="0"/>
           </a:p>

</xml_diff>

<commit_message>
Deck slide 6: party check on regional decline; add region_by_administration table
Co-Authored-By: Claude Opus 5.5 <noreply@anthropic.com>
</commit_message>
<xml_diff>
--- a/presentation/Sentiment_Midterms_Summary.pptx
+++ b/presentation/Sentiment_Midterms_Summary.pptx
@@ -124,25 +124,25 @@
   <p:extLst>
     <p:ext uri="{521415D9-36F7-43E2-AB2F-B90AF26B5E84}">
       <p14:sectionLst xmlns:p14="http://schemas.microsoft.com/office/powerpoint/2010/main">
-        <p14:section name="Question" id="{36a789dd-e9de-a9b7-b2d2-844930be87b5}">
+        <p14:section name="Question" id="{4f6d6fa3-3d15-0d4b-47a6-317f1fd34761}">
           <p14:sldIdLst>
             <p14:sldId id="256"/>
             <p14:sldId id="257"/>
           </p14:sldIdLst>
         </p14:section>
-        <p14:section name="Approach" id="{3625bff1-aedb-5221-dc3b-5219b236a836}">
+        <p14:section name="Approach" id="{9798c8e5-13db-d484-1e6f-6ae432546b71}">
           <p14:sldIdLst>
             <p14:sldId id="258"/>
             <p14:sldId id="259"/>
           </p14:sldIdLst>
         </p14:section>
-        <p14:section name="Who" id="{4418e372-bfac-944d-87ec-be83591b55a1}">
+        <p14:section name="Who" id="{b5a56596-e12d-a3c7-71d3-fecfd552f89c}">
           <p14:sldIdLst>
             <p14:sldId id="260"/>
             <p14:sldId id="261"/>
           </p14:sldIdLst>
         </p14:section>
-        <p14:section name="Why" id="{218aec60-db49-84b7-666b-b50bc6ed1cbd}">
+        <p14:section name="Why" id="{a0672b59-8a78-24d7-0078-83b4f2424f3f}">
           <p14:sldIdLst>
             <p14:sldId id="262"/>
             <p14:sldId id="263"/>
@@ -151,20 +151,20 @@
             <p14:sldId id="266"/>
           </p14:sldIdLst>
         </p14:section>
-        <p14:section name="Media" id="{5de7b180-e585-7992-0e3e-251d019c90fe}">
+        <p14:section name="Media" id="{dd5d10db-f242-bfc2-4d29-93e08b88c197}">
           <p14:sldIdLst>
             <p14:sldId id="267"/>
             <p14:sldId id="268"/>
           </p14:sldIdLst>
         </p14:section>
-        <p14:section name="So what" id="{2c0db3ab-87bc-f4e8-ac92-0304ce89a299}">
+        <p14:section name="So what" id="{4fe285ab-3c70-b78c-608e-a71672f26355}">
           <p14:sldIdLst>
             <p14:sldId id="269"/>
             <p14:sldId id="270"/>
             <p14:sldId id="271"/>
           </p14:sldIdLst>
         </p14:section>
-        <p14:section name="Extra clarification" id="{c9239acd-8028-ee87-db36-4f1f7d03e35b}">
+        <p14:section name="Extra clarification" id="{18fbd0e5-d3ba-1b63-78b5-9d474a3c7815}">
           <p14:sldIdLst>
             <p14:sldId id="272"/>
             <p14:sldId id="273"/>
@@ -6178,7 +6178,7 @@
           <a:p>
             <a:r>
               <a:rPr lang="en-US" dirty="0"/>
-              <a:t>(30 s) Next we asked: is one region or one income group driving this? No. The Northeast, Midwest, South and West all fell by about 40 points. Low, middle and high earners all fell by about 40 points too. Since everyone fell together, the cause must be something national that hit everyone — which brings us to prices.</a:t>
+              <a:t>(30 s) Next we asked: is one region or one income group driving this? No. The Northeast, Midwest, South and West all fell by about 40 points. Low, middle and high earners all fell by about 40 points too. Since everyone fell together, the cause must be something national that hit everyone — which brings us to prices. And party doesn't skew this: 2019 and now are both under the same president. Comparing Biden years with Trump years, the Republican-leaning South fell about 7 points less than the coasts — the same flip happened in 2017 — but every region still fell.</a:t>
             </a:r>
             <a:endParaRPr lang="en-US" dirty="0"/>
           </a:p>
@@ -14810,7 +14810,7 @@
         </p:nvGraphicFramePr>
         <p:xfrm>
           <a:off x="548640" y="1234440"/>
-          <a:ext cx="5486400" cy="4343400"/>
+          <a:ext cx="5486400" cy="3931920"/>
         </p:xfrm>
         <a:graphic xmlns:a="http://schemas.openxmlformats.org/drawingml/2006/main">
           <a:graphicData uri="http://schemas.openxmlformats.org/drawingml/2006/chart">
@@ -14826,7 +14826,7 @@
         </p:nvGraphicFramePr>
         <p:xfrm>
           <a:off x="6217920" y="1234440"/>
-          <a:ext cx="5394960" cy="4343400"/>
+          <a:ext cx="5394960" cy="3931920"/>
         </p:xfrm>
         <a:graphic xmlns:a="http://schemas.openxmlformats.org/drawingml/2006/main">
           <a:graphicData uri="http://schemas.openxmlformats.org/drawingml/2006/chart">
@@ -14836,7 +14836,60 @@
       </p:graphicFrame>
       <p:sp>
         <p:nvSpPr>
-          <p:cNvPr id="5" name="Shape 1"/>
+          <p:cNvPr id="5" name="Text 1"/>
+          <p:cNvSpPr txBox="1"/>
+          <p:nvPr/>
+        </p:nvSpPr>
+        <p:spPr>
+          <a:xfrm>
+            <a:off x="548640" y="5193792"/>
+            <a:ext cx="11064240" cy="411480"/>
+          </a:xfrm>
+          <a:prstGeom prst="rect">
+            <a:avLst/>
+          </a:prstGeom>
+          <a:noFill/>
+          <a:ln/>
+        </p:spPr>
+        <p:txBody>
+          <a:bodyPr wrap="square" lIns="0" tIns="0" rIns="0" bIns="0" rtlCol="0" anchor="t"/>
+          <a:lstStyle/>
+          <a:p>
+            <a:pPr indent="0" marL="0">
+              <a:buNone/>
+            </a:pPr>
+            <a:r>
+              <a:rPr lang="en-US" sz="1200" b="1" i="1" dirty="0">
+                <a:solidFill>
+                  <a:srgbClr val="3A4150"/>
+                </a:solidFill>
+                <a:latin typeface="Calibri" pitchFamily="34" charset="0"/>
+                <a:ea typeface="Calibri" pitchFamily="34" charset="-122"/>
+                <a:cs typeface="Calibri" pitchFamily="34" charset="-120"/>
+              </a:rPr>
+              <a:t>Does party skew this? </a:t>
+            </a:r>
+            <a:pPr indent="0" marL="0">
+              <a:buNone/>
+            </a:pPr>
+            <a:r>
+              <a:rPr lang="en-US" sz="1200" i="1" dirty="0">
+                <a:solidFill>
+                  <a:srgbClr val="3A4150"/>
+                </a:solidFill>
+                <a:latin typeface="Calibri" pitchFamily="34" charset="0"/>
+                <a:ea typeface="Calibri" pitchFamily="34" charset="-122"/>
+                <a:cs typeface="Calibri" pitchFamily="34" charset="-120"/>
+              </a:rPr>
+              <a:t>No — 2019 and 2025–26 are both under the same president, so party cancels out. (Biden vs Trump years: the Republican-leaning South fell ~7 points less — a small tilt, the same flip seen in 2017.)</a:t>
+            </a:r>
+            <a:endParaRPr lang="en-US" sz="1200" dirty="0"/>
+          </a:p>
+        </p:txBody>
+      </p:sp>
+      <p:sp>
+        <p:nvSpPr>
+          <p:cNvPr id="6" name="Shape 2"/>
           <p:cNvSpPr/>
           <p:nvPr/>
         </p:nvSpPr>
@@ -14863,7 +14916,7 @@
       </p:sp>
       <p:sp>
         <p:nvSpPr>
-          <p:cNvPr id="6" name="Text 2"/>
+          <p:cNvPr id="7" name="Text 3"/>
           <p:cNvSpPr txBox="1"/>
           <p:nvPr/>
         </p:nvSpPr>

</xml_diff>